<commit_message>
fix: textos da feira (acolhimento sem 'maioria não é câncer', ROTINA, fontes das pistas) e gerador dos slides no repo
- FAQ 18 e acolhimento do checklist: estimativa, não diagnóstico; só o
  médico confirma (o Roberto contradizia o 'na maioria das vezes').
- Slide 3 ROTINA = o resto (< 1% e < 2x a média); slide 4: conta pura
  vai para as notas; slide 7 e FAQ 13: atenção primária e meta-análises.
- FAQ 4 e 14, pitch/slide 5 ('alarme de câncer'), checklist: banner com
  internet e conferência visual.
- Docs/feira/gerador-slides.cjs: gerador autocontido (pptxgenjs fora do
  package.json, instruções no topo); slides.pptx regerado por ele.

Co-Authored-By: Claude Opus 5.5 <noreply@anthropic.com>
</commit_message>
<xml_diff>
--- a/Docs/feira/slides.pptx
+++ b/Docs/feira/slides.pptx
@@ -113,33 +113,33 @@
   <p:extLst>
     <p:ext uri="{521415D9-36F7-43E2-AB2F-B90AF26B5E84}">
       <p14:sectionLst xmlns:p14="http://schemas.microsoft.com/office/powerpoint/2010/main">
-        <p14:section name="Abertura" id="{705d9674-56a8-c2d8-6cca-7a30661c29fe}">
+        <p14:section name="Abertura" id="{02bb8388-f36f-83b3-08ae-097019f62b2c}">
           <p14:sldIdLst>
             <p14:sldId id="256"/>
           </p14:sldIdLst>
         </p14:section>
-        <p14:section name="Problema" id="{14b75776-7d10-b463-7834-3eb214ba2eed}">
+        <p14:section name="Problema" id="{b4f4f385-df14-675d-b691-3168bbc6d178}">
           <p14:sldIdLst>
             <p14:sldId id="257"/>
           </p14:sldIdLst>
         </p14:section>
-        <p14:section name="Como funciona" id="{eb3f31d8-842c-a513-da4c-6a6600db3fb1}">
+        <p14:section name="Como funciona" id="{0f0fbfba-19aa-f58e-2926-82ee3f017905}">
           <p14:sldIdLst>
             <p14:sldId id="258"/>
           </p14:sldIdLst>
         </p14:section>
-        <p14:section name="Demonstração" id="{81f2d949-e036-1f18-5666-545cb45f9d0e}">
+        <p14:section name="Demonstração" id="{0cdbfb42-f167-8a13-5302-639613832c8d}">
           <p14:sldIdLst>
             <p14:sldId id="259"/>
             <p14:sldId id="260"/>
           </p14:sldIdLst>
         </p14:section>
-        <p14:section name="Base da IA" id="{d15d30d8-0f88-bcec-66e1-07b632971183}">
+        <p14:section name="Base da IA" id="{267a4dde-42ca-e23e-7f58-0e631a8f603d}">
           <p14:sldIdLst>
             <p14:sldId id="261"/>
           </p14:sldIdLst>
         </p14:section>
-        <p14:section name="Fecho" id="{3abba143-088c-af56-f2e2-fcc3d20735ea}">
+        <p14:section name="Fecho" id="{623de6c0-8ab9-26c1-7639-92cece0f668d}">
           <p14:sldIdLst>
             <p14:sldId id="262"/>
           </p14:sldIdLst>
@@ -1077,7 +1077,7 @@
           <a:p>
             <a:r>
               <a:rPr lang="en-US" dirty="0"/>
-              <a:t>Demo: login da médica, paciente Roberto, painel de riscos. Para a idade dele, a chance de câncer de intestino em 2 anos é cerca de 2 em 1.000 (0,157%). A balança registrou 84 para 76 kg em 90 dias, o hemograma tem anemia (Hb 10,9), o FIT deu positivo e ele contou que o intestino mudou. O risco passa de 20%: INVESTIGAR. Com 35 maços-ano e 8 anos sem fumar, também a TC de pulmão de baixa dose. A conta exata (45 a 68%, conforme as respostas) não aparece: Naive Bayes superestima pistas correlacionadas. Conferir os números na tela antes da apresentação.</a:t>
+              <a:t>Demo: login da médica, paciente Roberto, painel de riscos. Para a idade dele, a chance de câncer de intestino em 2 anos é cerca de 2 em 1.000 (0,157%). A balança registrou 84 para 76 kg em 90 dias, o hemograma tem anemia (Hb 10,9), o FIT deu positivo e ele contou que o intestino mudou. O risco passa de 20%: INVESTIGAR. Com 35 maços-ano e 8 anos sem fumar, também a TC de pulmão de baixa dose. Se perguntarem pelo número: a conta pura passa de 40% (45 a 68%, conforme as respostas), mas a tela mostra "≥ 20%" porque FIT e anemia andam juntos e o Naive Bayes superestima pistas correlacionadas. Conferir os números na tela antes da apresentação.</a:t>
             </a:r>
             <a:endParaRPr lang="en-US" dirty="0"/>
           </a:p>
@@ -4609,7 +4609,7 @@
                   <a:srgbClr val="0F172A"/>
                 </a:solidFill>
               </a:rPr>
-              <a:t>abaixo de 1%</a:t>
+              <a:t>o resto: &lt; 1% e &lt; 2× a média</a:t>
             </a:r>
             <a:endParaRPr lang="en-US" sz="1800" dirty="0"/>
           </a:p>
@@ -5300,18 +5300,7 @@
                   <a:srgbClr val="0F172A"/>
                 </a:solidFill>
               </a:rPr>
-              <a:t>avaliação médica com colonoscopia. Como ex-fumante, também a TC de pulmão de baixa dose (consenso 2024). </a:t>
-            </a:r>
-            <a:pPr indent="0" marL="0">
-              <a:buNone/>
-            </a:pPr>
-            <a:r>
-              <a:rPr lang="en-US" sz="1400" dirty="0">
-                <a:solidFill>
-                  <a:srgbClr val="475569"/>
-                </a:solidFill>
-              </a:rPr>
-              <a:t>A conta pura passa de 40%; a tela mostra "≥ 20%" porque FIT e anemia andam juntos.</a:t>
+              <a:t>avaliação médica com colonoscopia. Como ex-fumante, também a TC de pulmão de baixa dose (consenso 2024).</a:t>
             </a:r>
             <a:endParaRPr lang="en-US" sz="1400" dirty="0"/>
           </a:p>
@@ -6295,7 +6284,7 @@
                   <a:srgbClr val="0F172A"/>
                 </a:solidFill>
               </a:rPr>
-              <a:t>A IA também diz quando não há motivo para alarme.</a:t>
+              <a:t>A IA também diz quando não há motivo para alarme de câncer.</a:t>
             </a:r>
             <a:endParaRPr lang="en-US" sz="1100" dirty="0"/>
           </a:p>
@@ -8994,7 +8983,7 @@
                   <a:schemeClr val="bg1"/>
                 </a:solidFill>
               </a:rPr>
-              <a:t>Força das pistas vem de estudos ingleses de atenção primária.</a:t>
+              <a:t>Boa parte das pistas vem de estudos de atenção primária (CAPER, Reino Unido) e de meta-análises.</a:t>
             </a:r>
             <a:endParaRPr lang="en-US" sz="1500" dirty="0"/>
           </a:p>

</xml_diff>

<commit_message>
chore: URL nova do Render (healthinpulse-ib33) no QR, banner, slides, stand e docs
O serviço antigo (healthinpulse.onrender.com) está numa conta sem acesso e
ficou na versão anterior às correções da QA. O Blueprint foi recriado na
conta da turma; o nome `healthinpulse` já estava tomado, então a URL mudou.
QR, banner (HTML e PDF), slides, config do frontend, stand e docs apontam
para https://healthinpulse-ib33.onrender.com/teste.

Co-Authored-By: Claude Fable 5.1 <noreply@anthropic.com>
</commit_message>
<xml_diff>
--- a/Docs/feira/slides.pptx
+++ b/Docs/feira/slides.pptx
@@ -115,39 +115,39 @@
   <p:extLst>
     <p:ext uri="{521415D9-36F7-43E2-AB2F-B90AF26B5E84}">
       <p14:sectionLst xmlns:p14="http://schemas.microsoft.com/office/powerpoint/2010/main">
-        <p14:section name="Abertura" id="{423085fa-e94b-7b4e-8f0e-08a5ad8bd51b}">
+        <p14:section name="Abertura" id="{d3421418-10df-0948-3680-656ab9211e1d}">
           <p14:sldIdLst>
             <p14:sldId id="256"/>
           </p14:sldIdLst>
         </p14:section>
-        <p14:section name="Problema" id="{88cb2771-e419-6f17-dee5-51d4d8a2a28c}">
+        <p14:section name="Problema" id="{087c251b-73b1-25cf-0de5-3ef31b5d768e}">
           <p14:sldIdLst>
             <p14:sldId id="257"/>
           </p14:sldIdLst>
         </p14:section>
-        <p14:section name="Proposta" id="{7510d9d3-124f-def0-81ff-f973ba025c4a}">
+        <p14:section name="Proposta" id="{1e8e36ac-c30e-f7e6-2780-b4b9b369418c}">
           <p14:sldIdLst>
             <p14:sldId id="258"/>
           </p14:sldIdLst>
         </p14:section>
-        <p14:section name="Como funciona" id="{884f7b98-c009-0fa8-7c22-2dbee7d709f3}">
+        <p14:section name="Como funciona" id="{f3082416-0eb6-0ef0-2927-400d9150b1d5}">
           <p14:sldIdLst>
             <p14:sldId id="259"/>
           </p14:sldIdLst>
         </p14:section>
-        <p14:section name="Demonstração" id="{c73d1047-e062-b5e0-8763-4fe139c184fd}">
+        <p14:section name="Demonstração" id="{5c4ba5b2-72a6-0753-68b4-4cc59aa89897}">
           <p14:sldIdLst>
             <p14:sldId id="260"/>
             <p14:sldId id="261"/>
             <p14:sldId id="262"/>
           </p14:sldIdLst>
         </p14:section>
-        <p14:section name="Base da IA" id="{cf8f482e-2333-f795-0c1c-124b6702df57}">
+        <p14:section name="Base da IA" id="{f64beec4-5ef4-67ff-ef66-a948be0b0fe6}">
           <p14:sldIdLst>
             <p14:sldId id="263"/>
           </p14:sldIdLst>
         </p14:section>
-        <p14:section name="Fecho" id="{f93b621f-ef02-124b-26d1-e9901ea6c6dd}">
+        <p14:section name="Fecho" id="{213b48a7-1db2-eb64-2fa8-da449c1f5d0c}">
           <p14:sldIdLst>
             <p14:sldId id="264"/>
           </p14:sldIdLst>
@@ -11774,7 +11774,7 @@
       </p:sp>
       <p:pic>
         <p:nvPicPr>
-          <p:cNvPr id="8" name="Image 0" descr="QR code para https://healthinpulse.onrender.com/teste">    </p:cNvPr>
+          <p:cNvPr id="8" name="Image 0" descr="QR code para https://healthinpulse-ib33.onrender.com/teste">    </p:cNvPr>
           <p:cNvPicPr>
             <a:picLocks noChangeAspect="1"/>
           </p:cNvPicPr>
@@ -11904,7 +11904,7 @@
                 <a:ea typeface="Courier New" pitchFamily="34" charset="-122"/>
                 <a:cs typeface="Courier New" pitchFamily="34" charset="-120"/>
               </a:rPr>
-              <a:t>healthinpulse.onrender.com/teste</a:t>
+              <a:t>healthinpulse-ib33.onrender.com/teste</a:t>
             </a:r>
             <a:endParaRPr lang="en-US" sz="1100" dirty="0"/>
           </a:p>

</xml_diff>